<commit_message>
Add API spend + GPU hours to effort summary slide
</commit_message>
<xml_diff>
--- a/studies/lifetime_cost/reports/AdaptiveCache_talk.pptx
+++ b/studies/lifetime_cost/reports/AdaptiveCache_talk.pptx
@@ -6983,8 +6983,8 @@
         </p:nvSpPr>
         <p:spPr>
           <a:xfrm>
-            <a:off x="1097280" y="2331720"/>
-            <a:ext cx="3383280" cy="1691640"/>
+            <a:off x="960120" y="2331720"/>
+            <a:ext cx="2542032" cy="1691640"/>
           </a:xfrm>
           <a:prstGeom prst="rect">
             <a:avLst/>
@@ -7027,8 +7027,8 @@
         </p:nvSpPr>
         <p:spPr>
           <a:xfrm>
-            <a:off x="1097280" y="2423160"/>
-            <a:ext cx="3383280" cy="868680"/>
+            <a:off x="960120" y="2423160"/>
+            <a:ext cx="2542032" cy="868680"/>
           </a:xfrm>
           <a:prstGeom prst="rect">
             <a:avLst/>
@@ -7043,7 +7043,7 @@
           <a:p>
             <a:pPr algn="ctr"/>
             <a:r>
-              <a:rPr sz="4600" b="1" i="0">
+              <a:rPr sz="3600" b="1" i="0">
                 <a:solidFill>
                   <a:srgbClr val="E69F00"/>
                 </a:solidFill>
@@ -7062,8 +7062,8 @@
         </p:nvSpPr>
         <p:spPr>
           <a:xfrm>
-            <a:off x="1234439" y="3337560"/>
-            <a:ext cx="3108960" cy="594360"/>
+            <a:off x="1051560" y="3337560"/>
+            <a:ext cx="2359151" cy="594360"/>
           </a:xfrm>
           <a:prstGeom prst="rect">
             <a:avLst/>
@@ -7078,7 +7078,7 @@
           <a:p>
             <a:pPr algn="ctr"/>
             <a:r>
-              <a:rPr sz="1200" b="0" i="0">
+              <a:rPr sz="1100" b="0" i="0">
                 <a:solidFill>
                   <a:srgbClr val="6077C7"/>
                 </a:solidFill>
@@ -7097,8 +7097,8 @@
         </p:nvSpPr>
         <p:spPr>
           <a:xfrm>
-            <a:off x="4709160" y="2331720"/>
-            <a:ext cx="3383280" cy="1691640"/>
+            <a:off x="3685032" y="2331720"/>
+            <a:ext cx="2542032" cy="1691640"/>
           </a:xfrm>
           <a:prstGeom prst="rect">
             <a:avLst/>
@@ -7141,8 +7141,8 @@
         </p:nvSpPr>
         <p:spPr>
           <a:xfrm>
-            <a:off x="4709160" y="2423160"/>
-            <a:ext cx="3383280" cy="868680"/>
+            <a:off x="3685032" y="2423160"/>
+            <a:ext cx="2542032" cy="868680"/>
           </a:xfrm>
           <a:prstGeom prst="rect">
             <a:avLst/>
@@ -7157,7 +7157,7 @@
           <a:p>
             <a:pPr algn="ctr"/>
             <a:r>
-              <a:rPr sz="4600" b="1" i="0">
+              <a:rPr sz="3600" b="1" i="0">
                 <a:solidFill>
                   <a:srgbClr val="E69F00"/>
                 </a:solidFill>
@@ -7176,8 +7176,8 @@
         </p:nvSpPr>
         <p:spPr>
           <a:xfrm>
-            <a:off x="4846320" y="3337560"/>
-            <a:ext cx="3108960" cy="594360"/>
+            <a:off x="3776472" y="3337560"/>
+            <a:ext cx="2359151" cy="594360"/>
           </a:xfrm>
           <a:prstGeom prst="rect">
             <a:avLst/>
@@ -7192,13 +7192,13 @@
           <a:p>
             <a:pPr algn="ctr"/>
             <a:r>
-              <a:rPr sz="1200" b="0" i="0">
+              <a:rPr sz="1100" b="0" i="0">
                 <a:solidFill>
                   <a:srgbClr val="6077C7"/>
                 </a:solidFill>
                 <a:latin typeface="Calibri"/>
               </a:rPr>
-              <a:t>compaction strategies tested</a:t>
+              <a:t>compaction strategies</a:t>
             </a:r>
           </a:p>
         </p:txBody>
@@ -7211,8 +7211,8 @@
         </p:nvSpPr>
         <p:spPr>
           <a:xfrm>
-            <a:off x="8321040" y="2331720"/>
-            <a:ext cx="3383280" cy="1691640"/>
+            <a:off x="6409944" y="2331720"/>
+            <a:ext cx="2542032" cy="1691640"/>
           </a:xfrm>
           <a:prstGeom prst="rect">
             <a:avLst/>
@@ -7255,8 +7255,8 @@
         </p:nvSpPr>
         <p:spPr>
           <a:xfrm>
-            <a:off x="8321040" y="2423160"/>
-            <a:ext cx="3383280" cy="868680"/>
+            <a:off x="6409944" y="2423160"/>
+            <a:ext cx="2542032" cy="868680"/>
           </a:xfrm>
           <a:prstGeom prst="rect">
             <a:avLst/>
@@ -7271,7 +7271,7 @@
           <a:p>
             <a:pPr algn="ctr"/>
             <a:r>
-              <a:rPr sz="4600" b="1" i="0">
+              <a:rPr sz="3600" b="1" i="0">
                 <a:solidFill>
                   <a:srgbClr val="E69F00"/>
                 </a:solidFill>
@@ -7290,8 +7290,8 @@
         </p:nvSpPr>
         <p:spPr>
           <a:xfrm>
-            <a:off x="8458200" y="3337560"/>
-            <a:ext cx="3108960" cy="594360"/>
+            <a:off x="6501383" y="3337560"/>
+            <a:ext cx="2359151" cy="594360"/>
           </a:xfrm>
           <a:prstGeom prst="rect">
             <a:avLst/>
@@ -7306,7 +7306,7 @@
           <a:p>
             <a:pPr algn="ctr"/>
             <a:r>
-              <a:rPr sz="1200" b="0" i="0">
+              <a:rPr sz="1100" b="0" i="0">
                 <a:solidFill>
                   <a:srgbClr val="6077C7"/>
                 </a:solidFill>
@@ -7325,8 +7325,8 @@
         </p:nvSpPr>
         <p:spPr>
           <a:xfrm>
-            <a:off x="1097280" y="4206240"/>
-            <a:ext cx="3383280" cy="1691640"/>
+            <a:off x="9134856" y="2331720"/>
+            <a:ext cx="2542032" cy="1691640"/>
           </a:xfrm>
           <a:prstGeom prst="rect">
             <a:avLst/>
@@ -7369,8 +7369,8 @@
         </p:nvSpPr>
         <p:spPr>
           <a:xfrm>
-            <a:off x="1097280" y="4297679"/>
-            <a:ext cx="3383280" cy="868680"/>
+            <a:off x="9134856" y="2423160"/>
+            <a:ext cx="2542032" cy="868680"/>
           </a:xfrm>
           <a:prstGeom prst="rect">
             <a:avLst/>
@@ -7385,7 +7385,7 @@
           <a:p>
             <a:pPr algn="ctr"/>
             <a:r>
-              <a:rPr sz="4600" b="1" i="0">
+              <a:rPr sz="3600" b="1" i="0">
                 <a:solidFill>
                   <a:srgbClr val="E69F00"/>
                 </a:solidFill>
@@ -7404,8 +7404,8 @@
         </p:nvSpPr>
         <p:spPr>
           <a:xfrm>
-            <a:off x="1234439" y="5212079"/>
-            <a:ext cx="3108960" cy="594360"/>
+            <a:off x="9226296" y="3337560"/>
+            <a:ext cx="2359151" cy="594360"/>
           </a:xfrm>
           <a:prstGeom prst="rect">
             <a:avLst/>
@@ -7420,13 +7420,13 @@
           <a:p>
             <a:pPr algn="ctr"/>
             <a:r>
-              <a:rPr sz="1200" b="0" i="0">
+              <a:rPr sz="1100" b="0" i="0">
                 <a:solidFill>
                   <a:srgbClr val="6077C7"/>
                 </a:solidFill>
                 <a:latin typeface="Calibri"/>
               </a:rPr>
-              <a:t>benchmarks · SWE-bench Lite, τ-bench, long-doc</a:t>
+              <a:t>benchmarks</a:t>
             </a:r>
           </a:p>
         </p:txBody>
@@ -7439,8 +7439,8 @@
         </p:nvSpPr>
         <p:spPr>
           <a:xfrm>
-            <a:off x="4709160" y="4206240"/>
-            <a:ext cx="3383280" cy="1691640"/>
+            <a:off x="960120" y="4206240"/>
+            <a:ext cx="2542032" cy="1691640"/>
           </a:xfrm>
           <a:prstGeom prst="rect">
             <a:avLst/>
@@ -7483,8 +7483,8 @@
         </p:nvSpPr>
         <p:spPr>
           <a:xfrm>
-            <a:off x="4709160" y="4297679"/>
-            <a:ext cx="3383280" cy="868680"/>
+            <a:off x="960120" y="4297679"/>
+            <a:ext cx="2542032" cy="868680"/>
           </a:xfrm>
           <a:prstGeom prst="rect">
             <a:avLst/>
@@ -7499,7 +7499,7 @@
           <a:p>
             <a:pPr algn="ctr"/>
             <a:r>
-              <a:rPr sz="4600" b="1" i="0">
+              <a:rPr sz="3600" b="1" i="0">
                 <a:solidFill>
                   <a:srgbClr val="E69F00"/>
                 </a:solidFill>
@@ -7518,8 +7518,8 @@
         </p:nvSpPr>
         <p:spPr>
           <a:xfrm>
-            <a:off x="4846320" y="5212079"/>
-            <a:ext cx="3108960" cy="594360"/>
+            <a:off x="1051560" y="5212079"/>
+            <a:ext cx="2359151" cy="594360"/>
           </a:xfrm>
           <a:prstGeom prst="rect">
             <a:avLst/>
@@ -7534,13 +7534,13 @@
           <a:p>
             <a:pPr algn="ctr"/>
             <a:r>
-              <a:rPr sz="1200" b="0" i="0">
+              <a:rPr sz="1100" b="0" i="0">
                 <a:solidFill>
                   <a:srgbClr val="6077C7"/>
                 </a:solidFill>
                 <a:latin typeface="Calibri"/>
               </a:rPr>
-              <a:t>input tokens (cached + uncached)</a:t>
+              <a:t>input tokens</a:t>
             </a:r>
           </a:p>
         </p:txBody>
@@ -7553,8 +7553,8 @@
         </p:nvSpPr>
         <p:spPr>
           <a:xfrm>
-            <a:off x="8321040" y="4206240"/>
-            <a:ext cx="3383280" cy="1691640"/>
+            <a:off x="3685032" y="4206240"/>
+            <a:ext cx="2542032" cy="1691640"/>
           </a:xfrm>
           <a:prstGeom prst="rect">
             <a:avLst/>
@@ -7597,8 +7597,8 @@
         </p:nvSpPr>
         <p:spPr>
           <a:xfrm>
-            <a:off x="8321040" y="4297679"/>
-            <a:ext cx="3383280" cy="868680"/>
+            <a:off x="3685032" y="4297679"/>
+            <a:ext cx="2542032" cy="868680"/>
           </a:xfrm>
           <a:prstGeom prst="rect">
             <a:avLst/>
@@ -7613,7 +7613,7 @@
           <a:p>
             <a:pPr algn="ctr"/>
             <a:r>
-              <a:rPr sz="4600" b="1" i="0">
+              <a:rPr sz="3600" b="1" i="0">
                 <a:solidFill>
                   <a:srgbClr val="E69F00"/>
                 </a:solidFill>
@@ -7632,8 +7632,8 @@
         </p:nvSpPr>
         <p:spPr>
           <a:xfrm>
-            <a:off x="8458200" y="5212079"/>
-            <a:ext cx="3108960" cy="594360"/>
+            <a:off x="3776472" y="5212079"/>
+            <a:ext cx="2359151" cy="594360"/>
           </a:xfrm>
           <a:prstGeom prst="rect">
             <a:avLst/>
@@ -7648,7 +7648,7 @@
           <a:p>
             <a:pPr algn="ctr"/>
             <a:r>
-              <a:rPr sz="1200" b="0" i="0">
+              <a:rPr sz="1100" b="0" i="0">
                 <a:solidFill>
                   <a:srgbClr val="6077C7"/>
                 </a:solidFill>
@@ -7661,7 +7661,235 @@
       </p:sp>
       <p:sp>
         <p:nvSpPr>
-          <p:cNvPr id="24" name="TextBox 23"/>
+          <p:cNvPr id="24" name="Rectangle 23"/>
+          <p:cNvSpPr/>
+          <p:nvPr/>
+        </p:nvSpPr>
+        <p:spPr>
+          <a:xfrm>
+            <a:off x="6409944" y="4206240"/>
+            <a:ext cx="2542032" cy="1691640"/>
+          </a:xfrm>
+          <a:prstGeom prst="rect">
+            <a:avLst/>
+          </a:prstGeom>
+          <a:solidFill>
+            <a:srgbClr val="1E3A8A"/>
+          </a:solidFill>
+          <a:ln>
+            <a:noFill/>
+          </a:ln>
+          <a:effectLst/>
+        </p:spPr>
+        <p:style>
+          <a:lnRef idx="1">
+            <a:schemeClr val="accent1"/>
+          </a:lnRef>
+          <a:fillRef idx="3">
+            <a:schemeClr val="accent1"/>
+          </a:fillRef>
+          <a:effectRef idx="2">
+            <a:schemeClr val="accent1"/>
+          </a:effectRef>
+          <a:fontRef idx="minor">
+            <a:schemeClr val="lt1"/>
+          </a:fontRef>
+        </p:style>
+        <p:txBody>
+          <a:bodyPr rtlCol="0" anchor="ctr"/>
+          <a:lstStyle/>
+          <a:p>
+            <a:pPr algn="ctr"/>
+          </a:p>
+        </p:txBody>
+      </p:sp>
+      <p:sp>
+        <p:nvSpPr>
+          <p:cNvPr id="25" name="TextBox 24"/>
+          <p:cNvSpPr txBox="1"/>
+          <p:nvPr/>
+        </p:nvSpPr>
+        <p:spPr>
+          <a:xfrm>
+            <a:off x="6409944" y="4297679"/>
+            <a:ext cx="2542032" cy="868680"/>
+          </a:xfrm>
+          <a:prstGeom prst="rect">
+            <a:avLst/>
+          </a:prstGeom>
+          <a:noFill/>
+        </p:spPr>
+        <p:txBody>
+          <a:bodyPr wrap="square" lIns="0" rIns="0" tIns="0" bIns="0" anchor="ctr">
+            <a:spAutoFit/>
+          </a:bodyPr>
+          <a:lstStyle/>
+          <a:p>
+            <a:pPr algn="ctr"/>
+            <a:r>
+              <a:rPr sz="3600" b="1" i="0">
+                <a:solidFill>
+                  <a:srgbClr val="E69F00"/>
+                </a:solidFill>
+                <a:latin typeface="Calibri"/>
+              </a:rPr>
+              <a:t>$200+</a:t>
+            </a:r>
+          </a:p>
+        </p:txBody>
+      </p:sp>
+      <p:sp>
+        <p:nvSpPr>
+          <p:cNvPr id="26" name="TextBox 25"/>
+          <p:cNvSpPr txBox="1"/>
+          <p:nvPr/>
+        </p:nvSpPr>
+        <p:spPr>
+          <a:xfrm>
+            <a:off x="6501383" y="5212079"/>
+            <a:ext cx="2359151" cy="594360"/>
+          </a:xfrm>
+          <a:prstGeom prst="rect">
+            <a:avLst/>
+          </a:prstGeom>
+          <a:noFill/>
+        </p:spPr>
+        <p:txBody>
+          <a:bodyPr wrap="square" lIns="0" rIns="0" tIns="0" bIns="0">
+            <a:spAutoFit/>
+          </a:bodyPr>
+          <a:lstStyle/>
+          <a:p>
+            <a:pPr algn="ctr"/>
+            <a:r>
+              <a:rPr sz="1100" b="0" i="0">
+                <a:solidFill>
+                  <a:srgbClr val="6077C7"/>
+                </a:solidFill>
+                <a:latin typeface="Calibri"/>
+              </a:rPr>
+              <a:t>Anthropic API spend</a:t>
+            </a:r>
+          </a:p>
+        </p:txBody>
+      </p:sp>
+      <p:sp>
+        <p:nvSpPr>
+          <p:cNvPr id="27" name="Rectangle 26"/>
+          <p:cNvSpPr/>
+          <p:nvPr/>
+        </p:nvSpPr>
+        <p:spPr>
+          <a:xfrm>
+            <a:off x="9134856" y="4206240"/>
+            <a:ext cx="2542032" cy="1691640"/>
+          </a:xfrm>
+          <a:prstGeom prst="rect">
+            <a:avLst/>
+          </a:prstGeom>
+          <a:solidFill>
+            <a:srgbClr val="1E3A8A"/>
+          </a:solidFill>
+          <a:ln>
+            <a:noFill/>
+          </a:ln>
+          <a:effectLst/>
+        </p:spPr>
+        <p:style>
+          <a:lnRef idx="1">
+            <a:schemeClr val="accent1"/>
+          </a:lnRef>
+          <a:fillRef idx="3">
+            <a:schemeClr val="accent1"/>
+          </a:fillRef>
+          <a:effectRef idx="2">
+            <a:schemeClr val="accent1"/>
+          </a:effectRef>
+          <a:fontRef idx="minor">
+            <a:schemeClr val="lt1"/>
+          </a:fontRef>
+        </p:style>
+        <p:txBody>
+          <a:bodyPr rtlCol="0" anchor="ctr"/>
+          <a:lstStyle/>
+          <a:p>
+            <a:pPr algn="ctr"/>
+          </a:p>
+        </p:txBody>
+      </p:sp>
+      <p:sp>
+        <p:nvSpPr>
+          <p:cNvPr id="28" name="TextBox 27"/>
+          <p:cNvSpPr txBox="1"/>
+          <p:nvPr/>
+        </p:nvSpPr>
+        <p:spPr>
+          <a:xfrm>
+            <a:off x="9134856" y="4297679"/>
+            <a:ext cx="2542032" cy="868680"/>
+          </a:xfrm>
+          <a:prstGeom prst="rect">
+            <a:avLst/>
+          </a:prstGeom>
+          <a:noFill/>
+        </p:spPr>
+        <p:txBody>
+          <a:bodyPr wrap="square" lIns="0" rIns="0" tIns="0" bIns="0" anchor="ctr">
+            <a:spAutoFit/>
+          </a:bodyPr>
+          <a:lstStyle/>
+          <a:p>
+            <a:pPr algn="ctr"/>
+            <a:r>
+              <a:rPr sz="3600" b="1" i="0">
+                <a:solidFill>
+                  <a:srgbClr val="E69F00"/>
+                </a:solidFill>
+                <a:latin typeface="Calibri"/>
+              </a:rPr>
+              <a:t>100+</a:t>
+            </a:r>
+          </a:p>
+        </p:txBody>
+      </p:sp>
+      <p:sp>
+        <p:nvSpPr>
+          <p:cNvPr id="29" name="TextBox 28"/>
+          <p:cNvSpPr txBox="1"/>
+          <p:nvPr/>
+        </p:nvSpPr>
+        <p:spPr>
+          <a:xfrm>
+            <a:off x="9226296" y="5212079"/>
+            <a:ext cx="2359151" cy="594360"/>
+          </a:xfrm>
+          <a:prstGeom prst="rect">
+            <a:avLst/>
+          </a:prstGeom>
+          <a:noFill/>
+        </p:spPr>
+        <p:txBody>
+          <a:bodyPr wrap="square" lIns="0" rIns="0" tIns="0" bIns="0">
+            <a:spAutoFit/>
+          </a:bodyPr>
+          <a:lstStyle/>
+          <a:p>
+            <a:pPr algn="ctr"/>
+            <a:r>
+              <a:rPr sz="1100" b="0" i="0">
+                <a:solidFill>
+                  <a:srgbClr val="6077C7"/>
+                </a:solidFill>
+                <a:latin typeface="Calibri"/>
+              </a:rPr>
+              <a:t>GPU hours (Blackwell + SEAS + Modal)</a:t>
+            </a:r>
+          </a:p>
+        </p:txBody>
+      </p:sp>
+      <p:sp>
+        <p:nvSpPr>
+          <p:cNvPr id="30" name="TextBox 29"/>
           <p:cNvSpPr txBox="1"/>
           <p:nvPr/>
         </p:nvSpPr>
@@ -7696,7 +7924,7 @@
       </p:sp>
       <p:sp>
         <p:nvSpPr>
-          <p:cNvPr id="25" name="TextBox 24"/>
+          <p:cNvPr id="31" name="TextBox 30"/>
           <p:cNvSpPr txBox="1"/>
           <p:nvPr/>
         </p:nvSpPr>
@@ -7731,7 +7959,7 @@
       </p:sp>
       <p:sp>
         <p:nvSpPr>
-          <p:cNvPr id="26" name="TextBox 25"/>
+          <p:cNvPr id="32" name="TextBox 31"/>
           <p:cNvSpPr txBox="1"/>
           <p:nvPr/>
         </p:nvSpPr>

</xml_diff>